<commit_message>
General settings- Handle the form
</commit_message>
<xml_diff>
--- a/.lessons/63 General settings/2 General settings- Handle the form/1.pptx
+++ b/.lessons/63 General settings/2 General settings- Handle the form/1.pptx
@@ -6,10 +6,17 @@
   </p:sldMasterIdLst>
   <p:sldIdLst>
     <p:sldId id="415" r:id="rId2"/>
-    <p:sldId id="416" r:id="rId3"/>
-    <p:sldId id="417" r:id="rId4"/>
-    <p:sldId id="418" r:id="rId5"/>
-    <p:sldId id="419" r:id="rId6"/>
+    <p:sldId id="420" r:id="rId3"/>
+    <p:sldId id="421" r:id="rId4"/>
+    <p:sldId id="416" r:id="rId5"/>
+    <p:sldId id="417" r:id="rId6"/>
+    <p:sldId id="418" r:id="rId7"/>
+    <p:sldId id="422" r:id="rId8"/>
+    <p:sldId id="419" r:id="rId9"/>
+    <p:sldId id="423" r:id="rId10"/>
+    <p:sldId id="425" r:id="rId11"/>
+    <p:sldId id="426" r:id="rId12"/>
+    <p:sldId id="424" r:id="rId13"/>
   </p:sldIdLst>
   <p:sldSz cx="12192000" cy="6858000"/>
   <p:notesSz cx="6858000" cy="9144000"/>
@@ -263,7 +270,7 @@
           <a:p>
             <a:fld id="{3E102D2E-813C-461C-9963-687A650C48C0}" type="datetimeFigureOut">
               <a:rPr lang="en-US" smtClean="0"/>
-              <a:t>12/24/2025</a:t>
+              <a:t>12/29/2025</a:t>
             </a:fld>
             <a:endParaRPr lang="en-US"/>
           </a:p>
@@ -461,7 +468,7 @@
           <a:p>
             <a:fld id="{3E102D2E-813C-461C-9963-687A650C48C0}" type="datetimeFigureOut">
               <a:rPr lang="en-US" smtClean="0"/>
-              <a:t>12/24/2025</a:t>
+              <a:t>12/29/2025</a:t>
             </a:fld>
             <a:endParaRPr lang="en-US"/>
           </a:p>
@@ -669,7 +676,7 @@
           <a:p>
             <a:fld id="{3E102D2E-813C-461C-9963-687A650C48C0}" type="datetimeFigureOut">
               <a:rPr lang="en-US" smtClean="0"/>
-              <a:t>12/24/2025</a:t>
+              <a:t>12/29/2025</a:t>
             </a:fld>
             <a:endParaRPr lang="en-US"/>
           </a:p>
@@ -867,7 +874,7 @@
           <a:p>
             <a:fld id="{3E102D2E-813C-461C-9963-687A650C48C0}" type="datetimeFigureOut">
               <a:rPr lang="en-US" smtClean="0"/>
-              <a:t>12/24/2025</a:t>
+              <a:t>12/29/2025</a:t>
             </a:fld>
             <a:endParaRPr lang="en-US"/>
           </a:p>
@@ -1142,7 +1149,7 @@
           <a:p>
             <a:fld id="{3E102D2E-813C-461C-9963-687A650C48C0}" type="datetimeFigureOut">
               <a:rPr lang="en-US" smtClean="0"/>
-              <a:t>12/24/2025</a:t>
+              <a:t>12/29/2025</a:t>
             </a:fld>
             <a:endParaRPr lang="en-US"/>
           </a:p>
@@ -1407,7 +1414,7 @@
           <a:p>
             <a:fld id="{3E102D2E-813C-461C-9963-687A650C48C0}" type="datetimeFigureOut">
               <a:rPr lang="en-US" smtClean="0"/>
-              <a:t>12/24/2025</a:t>
+              <a:t>12/29/2025</a:t>
             </a:fld>
             <a:endParaRPr lang="en-US"/>
           </a:p>
@@ -1819,7 +1826,7 @@
           <a:p>
             <a:fld id="{3E102D2E-813C-461C-9963-687A650C48C0}" type="datetimeFigureOut">
               <a:rPr lang="en-US" smtClean="0"/>
-              <a:t>12/24/2025</a:t>
+              <a:t>12/29/2025</a:t>
             </a:fld>
             <a:endParaRPr lang="en-US"/>
           </a:p>
@@ -1960,7 +1967,7 @@
           <a:p>
             <a:fld id="{3E102D2E-813C-461C-9963-687A650C48C0}" type="datetimeFigureOut">
               <a:rPr lang="en-US" smtClean="0"/>
-              <a:t>12/24/2025</a:t>
+              <a:t>12/29/2025</a:t>
             </a:fld>
             <a:endParaRPr lang="en-US"/>
           </a:p>
@@ -2073,7 +2080,7 @@
           <a:p>
             <a:fld id="{3E102D2E-813C-461C-9963-687A650C48C0}" type="datetimeFigureOut">
               <a:rPr lang="en-US" smtClean="0"/>
-              <a:t>12/24/2025</a:t>
+              <a:t>12/29/2025</a:t>
             </a:fld>
             <a:endParaRPr lang="en-US"/>
           </a:p>
@@ -2384,7 +2391,7 @@
           <a:p>
             <a:fld id="{3E102D2E-813C-461C-9963-687A650C48C0}" type="datetimeFigureOut">
               <a:rPr lang="en-US" smtClean="0"/>
-              <a:t>12/24/2025</a:t>
+              <a:t>12/29/2025</a:t>
             </a:fld>
             <a:endParaRPr lang="en-US"/>
           </a:p>
@@ -2672,7 +2679,7 @@
           <a:p>
             <a:fld id="{3E102D2E-813C-461C-9963-687A650C48C0}" type="datetimeFigureOut">
               <a:rPr lang="en-US" smtClean="0"/>
-              <a:t>12/24/2025</a:t>
+              <a:t>12/29/2025</a:t>
             </a:fld>
             <a:endParaRPr lang="en-US"/>
           </a:p>
@@ -2913,7 +2920,7 @@
           <a:p>
             <a:fld id="{3E102D2E-813C-461C-9963-687A650C48C0}" type="datetimeFigureOut">
               <a:rPr lang="en-US" smtClean="0"/>
-              <a:t>12/24/2025</a:t>
+              <a:t>12/29/2025</a:t>
             </a:fld>
             <a:endParaRPr lang="en-US"/>
           </a:p>
@@ -3351,7 +3358,7 @@
         <p:spPr>
           <a:xfrm>
             <a:off x="0" y="0"/>
-            <a:ext cx="12192000" cy="355354"/>
+            <a:ext cx="2549236" cy="2155847"/>
           </a:xfrm>
           <a:prstGeom prst="rect">
             <a:avLst/>
@@ -3371,21 +3378,116 @@
               <a:buNone/>
             </a:pPr>
             <a:r>
-              <a:rPr kumimoji="0" lang="en-US" altLang="en-US" sz="1300" b="0" i="0" u="none" strike="noStrike" cap="none" normalizeH="0" baseline="0">
-                <a:ln>
-                  <a:noFill/>
-                </a:ln>
-                <a:solidFill>
-                  <a:schemeClr val="tx1"/>
-                </a:solidFill>
-                <a:effectLst/>
+              <a:rPr lang="az-Latn-AZ" altLang="en-US" sz="1300">
                 <a:latin typeface="Arial" panose="020B0604020202020204" pitchFamily="34" charset="0"/>
               </a:rPr>
-              <a:t>.</a:t>
-            </a:r>
-          </a:p>
-        </p:txBody>
-      </p:sp>
+              <a:t>settings.py adında fayl yaradaraq onun içini şəkildəki kimi doldururuq.</a:t>
+            </a:r>
+          </a:p>
+          <a:p>
+            <a:pPr>
+              <a:lnSpc>
+                <a:spcPct val="150000"/>
+              </a:lnSpc>
+              <a:buNone/>
+            </a:pPr>
+            <a:endParaRPr kumimoji="0" lang="az-Latn-AZ" altLang="en-US" sz="1300" b="0" i="0" u="none" strike="noStrike" cap="none" normalizeH="0" baseline="0">
+              <a:ln>
+                <a:noFill/>
+              </a:ln>
+              <a:solidFill>
+                <a:schemeClr val="tx1"/>
+              </a:solidFill>
+              <a:effectLst/>
+              <a:latin typeface="Arial" panose="020B0604020202020204" pitchFamily="34" charset="0"/>
+            </a:endParaRPr>
+          </a:p>
+          <a:p>
+            <a:pPr>
+              <a:lnSpc>
+                <a:spcPct val="150000"/>
+              </a:lnSpc>
+              <a:buNone/>
+            </a:pPr>
+            <a:r>
+              <a:rPr lang="az-Latn-AZ" altLang="en-US" sz="1300">
+                <a:latin typeface="Arial" panose="020B0604020202020204" pitchFamily="34" charset="0"/>
+              </a:rPr>
+              <a:t>Bu məlumatlar internetdən götürülərək buraya yerləşdirilmişdir.</a:t>
+            </a:r>
+            <a:endParaRPr kumimoji="0" lang="en-US" altLang="en-US" sz="1300" b="0" i="0" u="none" strike="noStrike" cap="none" normalizeH="0" baseline="0">
+              <a:ln>
+                <a:noFill/>
+              </a:ln>
+              <a:solidFill>
+                <a:schemeClr val="tx1"/>
+              </a:solidFill>
+              <a:effectLst/>
+              <a:latin typeface="Arial" panose="020B0604020202020204" pitchFamily="34" charset="0"/>
+            </a:endParaRPr>
+          </a:p>
+        </p:txBody>
+      </p:sp>
+      <p:pic>
+        <p:nvPicPr>
+          <p:cNvPr id="4" name="Picture 3">
+            <a:extLst>
+              <a:ext uri="{FF2B5EF4-FFF2-40B4-BE49-F238E27FC236}">
+                <a16:creationId xmlns:a16="http://schemas.microsoft.com/office/drawing/2014/main" id="{D7B99207-41F5-E4D1-FBE6-BB6088B4A961}"/>
+              </a:ext>
+            </a:extLst>
+          </p:cNvPr>
+          <p:cNvPicPr>
+            <a:picLocks noChangeAspect="1"/>
+          </p:cNvPicPr>
+          <p:nvPr/>
+        </p:nvPicPr>
+        <p:blipFill>
+          <a:blip r:embed="rId2"/>
+          <a:stretch>
+            <a:fillRect/>
+          </a:stretch>
+        </p:blipFill>
+        <p:spPr>
+          <a:xfrm>
+            <a:off x="2549236" y="0"/>
+            <a:ext cx="3860696" cy="6858000"/>
+          </a:xfrm>
+          <a:prstGeom prst="rect">
+            <a:avLst/>
+          </a:prstGeom>
+        </p:spPr>
+      </p:pic>
+      <p:pic>
+        <p:nvPicPr>
+          <p:cNvPr id="6" name="Picture 5">
+            <a:extLst>
+              <a:ext uri="{FF2B5EF4-FFF2-40B4-BE49-F238E27FC236}">
+                <a16:creationId xmlns:a16="http://schemas.microsoft.com/office/drawing/2014/main" id="{645E8510-A8F8-C525-5959-6782F49ADE1E}"/>
+              </a:ext>
+            </a:extLst>
+          </p:cNvPr>
+          <p:cNvPicPr>
+            <a:picLocks noChangeAspect="1"/>
+          </p:cNvPicPr>
+          <p:nvPr/>
+        </p:nvPicPr>
+        <p:blipFill>
+          <a:blip r:embed="rId3"/>
+          <a:stretch>
+            <a:fillRect/>
+          </a:stretch>
+        </p:blipFill>
+        <p:spPr>
+          <a:xfrm>
+            <a:off x="7018667" y="0"/>
+            <a:ext cx="5173333" cy="6858000"/>
+          </a:xfrm>
+          <a:prstGeom prst="rect">
+            <a:avLst/>
+          </a:prstGeom>
+        </p:spPr>
+      </p:pic>
     </p:spTree>
     <p:extLst>
       <p:ext uri="{BB962C8B-B14F-4D97-AF65-F5344CB8AC3E}">
@@ -3399,7 +3501,587 @@
 </p:sld>
 </file>
 
+<file path=ppt/slides/slide10.xml><?xml version="1.0" encoding="utf-8"?>
+<p:sld xmlns:a="http://schemas.openxmlformats.org/drawingml/2006/main" xmlns:r="http://schemas.openxmlformats.org/officeDocument/2006/relationships" xmlns:p="http://schemas.openxmlformats.org/presentationml/2006/main">
+  <p:cSld>
+    <p:spTree>
+      <p:nvGrpSpPr>
+        <p:cNvPr id="1" name="">
+          <a:extLst>
+            <a:ext uri="{FF2B5EF4-FFF2-40B4-BE49-F238E27FC236}">
+              <a16:creationId xmlns:a16="http://schemas.microsoft.com/office/drawing/2014/main" id="{E3DEA5AF-E68F-8FF1-7570-41721F3E6F82}"/>
+            </a:ext>
+          </a:extLst>
+        </p:cNvPr>
+        <p:cNvGrpSpPr/>
+        <p:nvPr/>
+      </p:nvGrpSpPr>
+      <p:grpSpPr>
+        <a:xfrm>
+          <a:off x="0" y="0"/>
+          <a:ext cx="0" cy="0"/>
+          <a:chOff x="0" y="0"/>
+          <a:chExt cx="0" cy="0"/>
+        </a:xfrm>
+      </p:grpSpPr>
+      <p:sp>
+        <p:nvSpPr>
+          <p:cNvPr id="3" name="TextBox 2">
+            <a:extLst>
+              <a:ext uri="{FF2B5EF4-FFF2-40B4-BE49-F238E27FC236}">
+                <a16:creationId xmlns:a16="http://schemas.microsoft.com/office/drawing/2014/main" id="{B72AC63D-CF1C-C869-305C-D5C71A5DA194}"/>
+              </a:ext>
+            </a:extLst>
+          </p:cNvPr>
+          <p:cNvSpPr txBox="1"/>
+          <p:nvPr/>
+        </p:nvSpPr>
+        <p:spPr>
+          <a:xfrm>
+            <a:off x="0" y="0"/>
+            <a:ext cx="12192000" cy="355354"/>
+          </a:xfrm>
+          <a:prstGeom prst="rect">
+            <a:avLst/>
+          </a:prstGeom>
+          <a:noFill/>
+        </p:spPr>
+        <p:txBody>
+          <a:bodyPr wrap="square">
+            <a:spAutoFit/>
+          </a:bodyPr>
+          <a:lstStyle/>
+          <a:p>
+            <a:pPr>
+              <a:lnSpc>
+                <a:spcPct val="150000"/>
+              </a:lnSpc>
+              <a:buNone/>
+            </a:pPr>
+            <a:r>
+              <a:rPr kumimoji="0" lang="en-US" altLang="en-US" sz="1300" b="0" i="0" u="none" strike="noStrike" cap="none" normalizeH="0" baseline="0">
+                <a:ln>
+                  <a:noFill/>
+                </a:ln>
+                <a:solidFill>
+                  <a:schemeClr val="tx1"/>
+                </a:solidFill>
+                <a:effectLst/>
+                <a:latin typeface="Arial" panose="020B0604020202020204" pitchFamily="34" charset="0"/>
+              </a:rPr>
+              <a:t>.</a:t>
+            </a:r>
+          </a:p>
+        </p:txBody>
+      </p:sp>
+      <p:pic>
+        <p:nvPicPr>
+          <p:cNvPr id="4" name="Picture 3">
+            <a:extLst>
+              <a:ext uri="{FF2B5EF4-FFF2-40B4-BE49-F238E27FC236}">
+                <a16:creationId xmlns:a16="http://schemas.microsoft.com/office/drawing/2014/main" id="{A714A2B5-781C-A58C-C22A-3857EEF267FA}"/>
+              </a:ext>
+            </a:extLst>
+          </p:cNvPr>
+          <p:cNvPicPr>
+            <a:picLocks noChangeAspect="1"/>
+          </p:cNvPicPr>
+          <p:nvPr/>
+        </p:nvPicPr>
+        <p:blipFill>
+          <a:blip r:embed="rId2"/>
+          <a:stretch>
+            <a:fillRect/>
+          </a:stretch>
+        </p:blipFill>
+        <p:spPr>
+          <a:xfrm>
+            <a:off x="0" y="334745"/>
+            <a:ext cx="12192000" cy="6188509"/>
+          </a:xfrm>
+          <a:prstGeom prst="rect">
+            <a:avLst/>
+          </a:prstGeom>
+          <a:solidFill>
+            <a:srgbClr val="FFFFFF">
+              <a:shade val="85000"/>
+            </a:srgbClr>
+          </a:solidFill>
+          <a:ln w="88900" cap="sq">
+            <a:solidFill>
+              <a:srgbClr val="FFFFFF"/>
+            </a:solidFill>
+            <a:miter lim="800000"/>
+          </a:ln>
+          <a:effectLst>
+            <a:outerShdw blurRad="55000" dist="18000" dir="5400000" algn="tl" rotWithShape="0">
+              <a:srgbClr val="000000">
+                <a:alpha val="40000"/>
+              </a:srgbClr>
+            </a:outerShdw>
+          </a:effectLst>
+          <a:scene3d>
+            <a:camera prst="orthographicFront"/>
+            <a:lightRig rig="twoPt" dir="t">
+              <a:rot lat="0" lon="0" rev="7200000"/>
+            </a:lightRig>
+          </a:scene3d>
+          <a:sp3d>
+            <a:bevelT w="25400" h="19050"/>
+            <a:contourClr>
+              <a:srgbClr val="FFFFFF"/>
+            </a:contourClr>
+          </a:sp3d>
+        </p:spPr>
+      </p:pic>
+    </p:spTree>
+    <p:extLst>
+      <p:ext uri="{BB962C8B-B14F-4D97-AF65-F5344CB8AC3E}">
+        <p14:creationId xmlns:p14="http://schemas.microsoft.com/office/powerpoint/2010/main" val="1460861631"/>
+      </p:ext>
+    </p:extLst>
+  </p:cSld>
+  <p:clrMapOvr>
+    <a:masterClrMapping/>
+  </p:clrMapOvr>
+</p:sld>
+</file>
+
+<file path=ppt/slides/slide11.xml><?xml version="1.0" encoding="utf-8"?>
+<p:sld xmlns:a="http://schemas.openxmlformats.org/drawingml/2006/main" xmlns:r="http://schemas.openxmlformats.org/officeDocument/2006/relationships" xmlns:p="http://schemas.openxmlformats.org/presentationml/2006/main">
+  <p:cSld>
+    <p:spTree>
+      <p:nvGrpSpPr>
+        <p:cNvPr id="1" name="">
+          <a:extLst>
+            <a:ext uri="{FF2B5EF4-FFF2-40B4-BE49-F238E27FC236}">
+              <a16:creationId xmlns:a16="http://schemas.microsoft.com/office/drawing/2014/main" id="{8C3B9A65-D251-D776-922A-C686120A8B86}"/>
+            </a:ext>
+          </a:extLst>
+        </p:cNvPr>
+        <p:cNvGrpSpPr/>
+        <p:nvPr/>
+      </p:nvGrpSpPr>
+      <p:grpSpPr>
+        <a:xfrm>
+          <a:off x="0" y="0"/>
+          <a:ext cx="0" cy="0"/>
+          <a:chOff x="0" y="0"/>
+          <a:chExt cx="0" cy="0"/>
+        </a:xfrm>
+      </p:grpSpPr>
+      <p:sp>
+        <p:nvSpPr>
+          <p:cNvPr id="3" name="TextBox 2">
+            <a:extLst>
+              <a:ext uri="{FF2B5EF4-FFF2-40B4-BE49-F238E27FC236}">
+                <a16:creationId xmlns:a16="http://schemas.microsoft.com/office/drawing/2014/main" id="{938DBA5A-38A3-2B1A-79B6-337D6156DC7C}"/>
+              </a:ext>
+            </a:extLst>
+          </p:cNvPr>
+          <p:cNvSpPr txBox="1"/>
+          <p:nvPr/>
+        </p:nvSpPr>
+        <p:spPr>
+          <a:xfrm>
+            <a:off x="0" y="0"/>
+            <a:ext cx="12192000" cy="355354"/>
+          </a:xfrm>
+          <a:prstGeom prst="rect">
+            <a:avLst/>
+          </a:prstGeom>
+          <a:noFill/>
+        </p:spPr>
+        <p:txBody>
+          <a:bodyPr wrap="square">
+            <a:spAutoFit/>
+          </a:bodyPr>
+          <a:lstStyle/>
+          <a:p>
+            <a:pPr>
+              <a:lnSpc>
+                <a:spcPct val="150000"/>
+              </a:lnSpc>
+              <a:buNone/>
+            </a:pPr>
+            <a:r>
+              <a:rPr kumimoji="0" lang="en-US" altLang="en-US" sz="1300" b="0" i="0" u="none" strike="noStrike" cap="none" normalizeH="0" baseline="0">
+                <a:ln>
+                  <a:noFill/>
+                </a:ln>
+                <a:solidFill>
+                  <a:schemeClr val="tx1"/>
+                </a:solidFill>
+                <a:effectLst/>
+                <a:latin typeface="Arial" panose="020B0604020202020204" pitchFamily="34" charset="0"/>
+              </a:rPr>
+              <a:t>.</a:t>
+            </a:r>
+          </a:p>
+        </p:txBody>
+      </p:sp>
+    </p:spTree>
+    <p:extLst>
+      <p:ext uri="{BB962C8B-B14F-4D97-AF65-F5344CB8AC3E}">
+        <p14:creationId xmlns:p14="http://schemas.microsoft.com/office/powerpoint/2010/main" val="3220326152"/>
+      </p:ext>
+    </p:extLst>
+  </p:cSld>
+  <p:clrMapOvr>
+    <a:masterClrMapping/>
+  </p:clrMapOvr>
+</p:sld>
+</file>
+
+<file path=ppt/slides/slide12.xml><?xml version="1.0" encoding="utf-8"?>
+<p:sld xmlns:a="http://schemas.openxmlformats.org/drawingml/2006/main" xmlns:r="http://schemas.openxmlformats.org/officeDocument/2006/relationships" xmlns:p="http://schemas.openxmlformats.org/presentationml/2006/main">
+  <p:cSld>
+    <p:spTree>
+      <p:nvGrpSpPr>
+        <p:cNvPr id="1" name="">
+          <a:extLst>
+            <a:ext uri="{FF2B5EF4-FFF2-40B4-BE49-F238E27FC236}">
+              <a16:creationId xmlns:a16="http://schemas.microsoft.com/office/drawing/2014/main" id="{9583009A-6385-E510-793A-69FC9DC80180}"/>
+            </a:ext>
+          </a:extLst>
+        </p:cNvPr>
+        <p:cNvGrpSpPr/>
+        <p:nvPr/>
+      </p:nvGrpSpPr>
+      <p:grpSpPr>
+        <a:xfrm>
+          <a:off x="0" y="0"/>
+          <a:ext cx="0" cy="0"/>
+          <a:chOff x="0" y="0"/>
+          <a:chExt cx="0" cy="0"/>
+        </a:xfrm>
+      </p:grpSpPr>
+      <p:sp>
+        <p:nvSpPr>
+          <p:cNvPr id="3" name="TextBox 2">
+            <a:extLst>
+              <a:ext uri="{FF2B5EF4-FFF2-40B4-BE49-F238E27FC236}">
+                <a16:creationId xmlns:a16="http://schemas.microsoft.com/office/drawing/2014/main" id="{A786C944-509D-F038-50D6-BE71D8BB8B0A}"/>
+              </a:ext>
+            </a:extLst>
+          </p:cNvPr>
+          <p:cNvSpPr txBox="1"/>
+          <p:nvPr/>
+        </p:nvSpPr>
+        <p:spPr>
+          <a:xfrm>
+            <a:off x="0" y="0"/>
+            <a:ext cx="12192000" cy="355354"/>
+          </a:xfrm>
+          <a:prstGeom prst="rect">
+            <a:avLst/>
+          </a:prstGeom>
+          <a:noFill/>
+        </p:spPr>
+        <p:txBody>
+          <a:bodyPr wrap="square">
+            <a:spAutoFit/>
+          </a:bodyPr>
+          <a:lstStyle/>
+          <a:p>
+            <a:pPr>
+              <a:lnSpc>
+                <a:spcPct val="150000"/>
+              </a:lnSpc>
+              <a:buNone/>
+            </a:pPr>
+            <a:r>
+              <a:rPr kumimoji="0" lang="en-US" altLang="en-US" sz="1300" b="0" i="0" u="none" strike="noStrike" cap="none" normalizeH="0" baseline="0">
+                <a:ln>
+                  <a:noFill/>
+                </a:ln>
+                <a:solidFill>
+                  <a:schemeClr val="tx1"/>
+                </a:solidFill>
+                <a:effectLst/>
+                <a:latin typeface="Arial" panose="020B0604020202020204" pitchFamily="34" charset="0"/>
+              </a:rPr>
+              <a:t>.</a:t>
+            </a:r>
+          </a:p>
+        </p:txBody>
+      </p:sp>
+    </p:spTree>
+    <p:extLst>
+      <p:ext uri="{BB962C8B-B14F-4D97-AF65-F5344CB8AC3E}">
+        <p14:creationId xmlns:p14="http://schemas.microsoft.com/office/powerpoint/2010/main" val="364570146"/>
+      </p:ext>
+    </p:extLst>
+  </p:cSld>
+  <p:clrMapOvr>
+    <a:masterClrMapping/>
+  </p:clrMapOvr>
+</p:sld>
+</file>
+
 <file path=ppt/slides/slide2.xml><?xml version="1.0" encoding="utf-8"?>
+<p:sld xmlns:a="http://schemas.openxmlformats.org/drawingml/2006/main" xmlns:r="http://schemas.openxmlformats.org/officeDocument/2006/relationships" xmlns:p="http://schemas.openxmlformats.org/presentationml/2006/main">
+  <p:cSld>
+    <p:spTree>
+      <p:nvGrpSpPr>
+        <p:cNvPr id="1" name="">
+          <a:extLst>
+            <a:ext uri="{FF2B5EF4-FFF2-40B4-BE49-F238E27FC236}">
+              <a16:creationId xmlns:a16="http://schemas.microsoft.com/office/drawing/2014/main" id="{0EAAB9A8-5431-3C05-AC48-87A9F572D061}"/>
+            </a:ext>
+          </a:extLst>
+        </p:cNvPr>
+        <p:cNvGrpSpPr/>
+        <p:nvPr/>
+      </p:nvGrpSpPr>
+      <p:grpSpPr>
+        <a:xfrm>
+          <a:off x="0" y="0"/>
+          <a:ext cx="0" cy="0"/>
+          <a:chOff x="0" y="0"/>
+          <a:chExt cx="0" cy="0"/>
+        </a:xfrm>
+      </p:grpSpPr>
+      <p:sp>
+        <p:nvSpPr>
+          <p:cNvPr id="3" name="TextBox 2">
+            <a:extLst>
+              <a:ext uri="{FF2B5EF4-FFF2-40B4-BE49-F238E27FC236}">
+                <a16:creationId xmlns:a16="http://schemas.microsoft.com/office/drawing/2014/main" id="{55D8CAFD-5FD8-E8D9-0416-DE27F90D5D2C}"/>
+              </a:ext>
+            </a:extLst>
+          </p:cNvPr>
+          <p:cNvSpPr txBox="1"/>
+          <p:nvPr/>
+        </p:nvSpPr>
+        <p:spPr>
+          <a:xfrm>
+            <a:off x="0" y="0"/>
+            <a:ext cx="12192000" cy="355354"/>
+          </a:xfrm>
+          <a:prstGeom prst="rect">
+            <a:avLst/>
+          </a:prstGeom>
+          <a:noFill/>
+        </p:spPr>
+        <p:txBody>
+          <a:bodyPr wrap="square">
+            <a:spAutoFit/>
+          </a:bodyPr>
+          <a:lstStyle/>
+          <a:p>
+            <a:pPr>
+              <a:lnSpc>
+                <a:spcPct val="150000"/>
+              </a:lnSpc>
+              <a:buNone/>
+            </a:pPr>
+            <a:r>
+              <a:rPr kumimoji="0" lang="en-US" altLang="en-US" sz="1300" b="0" i="0" u="none" strike="noStrike" cap="none" normalizeH="0" baseline="0">
+                <a:ln>
+                  <a:noFill/>
+                </a:ln>
+                <a:solidFill>
+                  <a:schemeClr val="tx1"/>
+                </a:solidFill>
+                <a:effectLst/>
+                <a:latin typeface="Arial" panose="020B0604020202020204" pitchFamily="34" charset="0"/>
+              </a:rPr>
+              <a:t>.</a:t>
+            </a:r>
+          </a:p>
+        </p:txBody>
+      </p:sp>
+      <p:pic>
+        <p:nvPicPr>
+          <p:cNvPr id="4" name="Picture 3">
+            <a:extLst>
+              <a:ext uri="{FF2B5EF4-FFF2-40B4-BE49-F238E27FC236}">
+                <a16:creationId xmlns:a16="http://schemas.microsoft.com/office/drawing/2014/main" id="{2FBE809B-DF1F-BD5F-5464-4319C258BC78}"/>
+              </a:ext>
+            </a:extLst>
+          </p:cNvPr>
+          <p:cNvPicPr>
+            <a:picLocks noChangeAspect="1"/>
+          </p:cNvPicPr>
+          <p:nvPr/>
+        </p:nvPicPr>
+        <p:blipFill>
+          <a:blip r:embed="rId2"/>
+          <a:stretch>
+            <a:fillRect/>
+          </a:stretch>
+        </p:blipFill>
+        <p:spPr>
+          <a:xfrm>
+            <a:off x="2030437" y="0"/>
+            <a:ext cx="8131126" cy="6858000"/>
+          </a:xfrm>
+          <a:prstGeom prst="rect">
+            <a:avLst/>
+          </a:prstGeom>
+        </p:spPr>
+      </p:pic>
+    </p:spTree>
+    <p:extLst>
+      <p:ext uri="{BB962C8B-B14F-4D97-AF65-F5344CB8AC3E}">
+        <p14:creationId xmlns:p14="http://schemas.microsoft.com/office/powerpoint/2010/main" val="1589600900"/>
+      </p:ext>
+    </p:extLst>
+  </p:cSld>
+  <p:clrMapOvr>
+    <a:masterClrMapping/>
+  </p:clrMapOvr>
+</p:sld>
+</file>
+
+<file path=ppt/slides/slide3.xml><?xml version="1.0" encoding="utf-8"?>
+<p:sld xmlns:a="http://schemas.openxmlformats.org/drawingml/2006/main" xmlns:r="http://schemas.openxmlformats.org/officeDocument/2006/relationships" xmlns:p="http://schemas.openxmlformats.org/presentationml/2006/main">
+  <p:cSld>
+    <p:spTree>
+      <p:nvGrpSpPr>
+        <p:cNvPr id="1" name="">
+          <a:extLst>
+            <a:ext uri="{FF2B5EF4-FFF2-40B4-BE49-F238E27FC236}">
+              <a16:creationId xmlns:a16="http://schemas.microsoft.com/office/drawing/2014/main" id="{ABEEEA2B-CE02-3AC6-BA8F-13D3D199570F}"/>
+            </a:ext>
+          </a:extLst>
+        </p:cNvPr>
+        <p:cNvGrpSpPr/>
+        <p:nvPr/>
+      </p:nvGrpSpPr>
+      <p:grpSpPr>
+        <a:xfrm>
+          <a:off x="0" y="0"/>
+          <a:ext cx="0" cy="0"/>
+          <a:chOff x="0" y="0"/>
+          <a:chExt cx="0" cy="0"/>
+        </a:xfrm>
+      </p:grpSpPr>
+      <p:sp>
+        <p:nvSpPr>
+          <p:cNvPr id="3" name="TextBox 2">
+            <a:extLst>
+              <a:ext uri="{FF2B5EF4-FFF2-40B4-BE49-F238E27FC236}">
+                <a16:creationId xmlns:a16="http://schemas.microsoft.com/office/drawing/2014/main" id="{261B06AF-A6E3-1CFA-244A-17926BBB79E6}"/>
+              </a:ext>
+            </a:extLst>
+          </p:cNvPr>
+          <p:cNvSpPr txBox="1"/>
+          <p:nvPr/>
+        </p:nvSpPr>
+        <p:spPr>
+          <a:xfrm>
+            <a:off x="0" y="0"/>
+            <a:ext cx="12192000" cy="355354"/>
+          </a:xfrm>
+          <a:prstGeom prst="rect">
+            <a:avLst/>
+          </a:prstGeom>
+          <a:noFill/>
+        </p:spPr>
+        <p:txBody>
+          <a:bodyPr wrap="square">
+            <a:spAutoFit/>
+          </a:bodyPr>
+          <a:lstStyle/>
+          <a:p>
+            <a:pPr>
+              <a:lnSpc>
+                <a:spcPct val="150000"/>
+              </a:lnSpc>
+              <a:buNone/>
+            </a:pPr>
+            <a:r>
+              <a:rPr kumimoji="0" lang="en-US" altLang="en-US" sz="1300" b="0" i="0" u="none" strike="noStrike" cap="none" normalizeH="0" baseline="0">
+                <a:ln>
+                  <a:noFill/>
+                </a:ln>
+                <a:solidFill>
+                  <a:schemeClr val="tx1"/>
+                </a:solidFill>
+                <a:effectLst/>
+                <a:latin typeface="Arial" panose="020B0604020202020204" pitchFamily="34" charset="0"/>
+              </a:rPr>
+              <a:t>.</a:t>
+            </a:r>
+          </a:p>
+        </p:txBody>
+      </p:sp>
+      <p:pic>
+        <p:nvPicPr>
+          <p:cNvPr id="4" name="Picture 3">
+            <a:extLst>
+              <a:ext uri="{FF2B5EF4-FFF2-40B4-BE49-F238E27FC236}">
+                <a16:creationId xmlns:a16="http://schemas.microsoft.com/office/drawing/2014/main" id="{0DE213FD-DA99-3CB5-955B-542D2F598FE6}"/>
+              </a:ext>
+            </a:extLst>
+          </p:cNvPr>
+          <p:cNvPicPr>
+            <a:picLocks noChangeAspect="1"/>
+          </p:cNvPicPr>
+          <p:nvPr/>
+        </p:nvPicPr>
+        <p:blipFill>
+          <a:blip r:embed="rId2"/>
+          <a:stretch>
+            <a:fillRect/>
+          </a:stretch>
+        </p:blipFill>
+        <p:spPr>
+          <a:xfrm>
+            <a:off x="0" y="215100"/>
+            <a:ext cx="12192000" cy="6427799"/>
+          </a:xfrm>
+          <a:prstGeom prst="rect">
+            <a:avLst/>
+          </a:prstGeom>
+          <a:solidFill>
+            <a:srgbClr val="FFFFFF">
+              <a:shade val="85000"/>
+            </a:srgbClr>
+          </a:solidFill>
+          <a:ln w="88900" cap="sq">
+            <a:solidFill>
+              <a:srgbClr val="FFFFFF"/>
+            </a:solidFill>
+            <a:miter lim="800000"/>
+          </a:ln>
+          <a:effectLst>
+            <a:outerShdw blurRad="55000" dist="18000" dir="5400000" algn="tl" rotWithShape="0">
+              <a:srgbClr val="000000">
+                <a:alpha val="40000"/>
+              </a:srgbClr>
+            </a:outerShdw>
+          </a:effectLst>
+          <a:scene3d>
+            <a:camera prst="orthographicFront"/>
+            <a:lightRig rig="twoPt" dir="t">
+              <a:rot lat="0" lon="0" rev="7200000"/>
+            </a:lightRig>
+          </a:scene3d>
+          <a:sp3d>
+            <a:bevelT w="25400" h="19050"/>
+            <a:contourClr>
+              <a:srgbClr val="FFFFFF"/>
+            </a:contourClr>
+          </a:sp3d>
+        </p:spPr>
+      </p:pic>
+    </p:spTree>
+    <p:extLst>
+      <p:ext uri="{BB962C8B-B14F-4D97-AF65-F5344CB8AC3E}">
+        <p14:creationId xmlns:p14="http://schemas.microsoft.com/office/powerpoint/2010/main" val="2791623931"/>
+      </p:ext>
+    </p:extLst>
+  </p:cSld>
+  <p:clrMapOvr>
+    <a:masterClrMapping/>
+  </p:clrMapOvr>
+</p:sld>
+</file>
+
+<file path=ppt/slides/slide4.xml><?xml version="1.0" encoding="utf-8"?>
 <p:sld xmlns:a="http://schemas.openxmlformats.org/drawingml/2006/main" xmlns:r="http://schemas.openxmlformats.org/officeDocument/2006/relationships" xmlns:p="http://schemas.openxmlformats.org/presentationml/2006/main">
   <p:cSld>
     <p:spTree>
@@ -3472,6 +4154,36 @@
           </a:p>
         </p:txBody>
       </p:sp>
+      <p:pic>
+        <p:nvPicPr>
+          <p:cNvPr id="4" name="Picture 3">
+            <a:extLst>
+              <a:ext uri="{FF2B5EF4-FFF2-40B4-BE49-F238E27FC236}">
+                <a16:creationId xmlns:a16="http://schemas.microsoft.com/office/drawing/2014/main" id="{DF4613A0-D630-43F5-6637-E3EFDB807258}"/>
+              </a:ext>
+            </a:extLst>
+          </p:cNvPr>
+          <p:cNvPicPr>
+            <a:picLocks noChangeAspect="1"/>
+          </p:cNvPicPr>
+          <p:nvPr/>
+        </p:nvPicPr>
+        <p:blipFill>
+          <a:blip r:embed="rId2"/>
+          <a:stretch>
+            <a:fillRect/>
+          </a:stretch>
+        </p:blipFill>
+        <p:spPr>
+          <a:xfrm>
+            <a:off x="1936229" y="0"/>
+            <a:ext cx="8319541" cy="6858000"/>
+          </a:xfrm>
+          <a:prstGeom prst="rect">
+            <a:avLst/>
+          </a:prstGeom>
+        </p:spPr>
+      </p:pic>
     </p:spTree>
     <p:extLst>
       <p:ext uri="{BB962C8B-B14F-4D97-AF65-F5344CB8AC3E}">
@@ -3485,7 +4197,7 @@
 </p:sld>
 </file>
 
-<file path=ppt/slides/slide3.xml><?xml version="1.0" encoding="utf-8"?>
+<file path=ppt/slides/slide5.xml><?xml version="1.0" encoding="utf-8"?>
 <p:sld xmlns:a="http://schemas.openxmlformats.org/drawingml/2006/main" xmlns:r="http://schemas.openxmlformats.org/officeDocument/2006/relationships" xmlns:p="http://schemas.openxmlformats.org/presentationml/2006/main">
   <p:cSld>
     <p:spTree>
@@ -3558,6 +4270,36 @@
           </a:p>
         </p:txBody>
       </p:sp>
+      <p:pic>
+        <p:nvPicPr>
+          <p:cNvPr id="4" name="Picture 3">
+            <a:extLst>
+              <a:ext uri="{FF2B5EF4-FFF2-40B4-BE49-F238E27FC236}">
+                <a16:creationId xmlns:a16="http://schemas.microsoft.com/office/drawing/2014/main" id="{143F2126-2035-5566-423C-19D25B064C8C}"/>
+              </a:ext>
+            </a:extLst>
+          </p:cNvPr>
+          <p:cNvPicPr>
+            <a:picLocks noChangeAspect="1"/>
+          </p:cNvPicPr>
+          <p:nvPr/>
+        </p:nvPicPr>
+        <p:blipFill>
+          <a:blip r:embed="rId2"/>
+          <a:stretch>
+            <a:fillRect/>
+          </a:stretch>
+        </p:blipFill>
+        <p:spPr>
+          <a:xfrm>
+            <a:off x="3312993" y="0"/>
+            <a:ext cx="5566014" cy="6858000"/>
+          </a:xfrm>
+          <a:prstGeom prst="rect">
+            <a:avLst/>
+          </a:prstGeom>
+        </p:spPr>
+      </p:pic>
     </p:spTree>
     <p:extLst>
       <p:ext uri="{BB962C8B-B14F-4D97-AF65-F5344CB8AC3E}">
@@ -3571,7 +4313,7 @@
 </p:sld>
 </file>
 
-<file path=ppt/slides/slide4.xml><?xml version="1.0" encoding="utf-8"?>
+<file path=ppt/slides/slide6.xml><?xml version="1.0" encoding="utf-8"?>
 <p:sld xmlns:a="http://schemas.openxmlformats.org/drawingml/2006/main" xmlns:r="http://schemas.openxmlformats.org/officeDocument/2006/relationships" xmlns:p="http://schemas.openxmlformats.org/presentationml/2006/main">
   <p:cSld>
     <p:spTree>
@@ -3644,6 +4386,66 @@
           </a:p>
         </p:txBody>
       </p:sp>
+      <p:pic>
+        <p:nvPicPr>
+          <p:cNvPr id="4" name="Picture 3">
+            <a:extLst>
+              <a:ext uri="{FF2B5EF4-FFF2-40B4-BE49-F238E27FC236}">
+                <a16:creationId xmlns:a16="http://schemas.microsoft.com/office/drawing/2014/main" id="{C834F27D-68CC-FCAE-FC5B-6D495B849A17}"/>
+              </a:ext>
+            </a:extLst>
+          </p:cNvPr>
+          <p:cNvPicPr>
+            <a:picLocks noChangeAspect="1"/>
+          </p:cNvPicPr>
+          <p:nvPr/>
+        </p:nvPicPr>
+        <p:blipFill>
+          <a:blip r:embed="rId2"/>
+          <a:stretch>
+            <a:fillRect/>
+          </a:stretch>
+        </p:blipFill>
+        <p:spPr>
+          <a:xfrm>
+            <a:off x="0" y="276006"/>
+            <a:ext cx="12192000" cy="6305987"/>
+          </a:xfrm>
+          <a:prstGeom prst="rect">
+            <a:avLst/>
+          </a:prstGeom>
+          <a:solidFill>
+            <a:srgbClr val="FFFFFF">
+              <a:shade val="85000"/>
+            </a:srgbClr>
+          </a:solidFill>
+          <a:ln w="88900" cap="sq">
+            <a:solidFill>
+              <a:srgbClr val="FFFFFF"/>
+            </a:solidFill>
+            <a:miter lim="800000"/>
+          </a:ln>
+          <a:effectLst>
+            <a:outerShdw blurRad="55000" dist="18000" dir="5400000" algn="tl" rotWithShape="0">
+              <a:srgbClr val="000000">
+                <a:alpha val="40000"/>
+              </a:srgbClr>
+            </a:outerShdw>
+          </a:effectLst>
+          <a:scene3d>
+            <a:camera prst="orthographicFront"/>
+            <a:lightRig rig="twoPt" dir="t">
+              <a:rot lat="0" lon="0" rev="7200000"/>
+            </a:lightRig>
+          </a:scene3d>
+          <a:sp3d>
+            <a:bevelT w="25400" h="19050"/>
+            <a:contourClr>
+              <a:srgbClr val="FFFFFF"/>
+            </a:contourClr>
+          </a:sp3d>
+        </p:spPr>
+      </p:pic>
     </p:spTree>
     <p:extLst>
       <p:ext uri="{BB962C8B-B14F-4D97-AF65-F5344CB8AC3E}">
@@ -3657,7 +4459,153 @@
 </p:sld>
 </file>
 
-<file path=ppt/slides/slide5.xml><?xml version="1.0" encoding="utf-8"?>
+<file path=ppt/slides/slide7.xml><?xml version="1.0" encoding="utf-8"?>
+<p:sld xmlns:a="http://schemas.openxmlformats.org/drawingml/2006/main" xmlns:r="http://schemas.openxmlformats.org/officeDocument/2006/relationships" xmlns:p="http://schemas.openxmlformats.org/presentationml/2006/main">
+  <p:cSld>
+    <p:spTree>
+      <p:nvGrpSpPr>
+        <p:cNvPr id="1" name="">
+          <a:extLst>
+            <a:ext uri="{FF2B5EF4-FFF2-40B4-BE49-F238E27FC236}">
+              <a16:creationId xmlns:a16="http://schemas.microsoft.com/office/drawing/2014/main" id="{4F680034-944C-D557-4EA9-6B8CD1A40329}"/>
+            </a:ext>
+          </a:extLst>
+        </p:cNvPr>
+        <p:cNvGrpSpPr/>
+        <p:nvPr/>
+      </p:nvGrpSpPr>
+      <p:grpSpPr>
+        <a:xfrm>
+          <a:off x="0" y="0"/>
+          <a:ext cx="0" cy="0"/>
+          <a:chOff x="0" y="0"/>
+          <a:chExt cx="0" cy="0"/>
+        </a:xfrm>
+      </p:grpSpPr>
+      <p:sp>
+        <p:nvSpPr>
+          <p:cNvPr id="3" name="TextBox 2">
+            <a:extLst>
+              <a:ext uri="{FF2B5EF4-FFF2-40B4-BE49-F238E27FC236}">
+                <a16:creationId xmlns:a16="http://schemas.microsoft.com/office/drawing/2014/main" id="{C8B4DB1D-6E63-127C-9389-BFAA5941605A}"/>
+              </a:ext>
+            </a:extLst>
+          </p:cNvPr>
+          <p:cNvSpPr txBox="1"/>
+          <p:nvPr/>
+        </p:nvSpPr>
+        <p:spPr>
+          <a:xfrm>
+            <a:off x="0" y="0"/>
+            <a:ext cx="12192000" cy="355354"/>
+          </a:xfrm>
+          <a:prstGeom prst="rect">
+            <a:avLst/>
+          </a:prstGeom>
+          <a:noFill/>
+        </p:spPr>
+        <p:txBody>
+          <a:bodyPr wrap="square">
+            <a:spAutoFit/>
+          </a:bodyPr>
+          <a:lstStyle/>
+          <a:p>
+            <a:pPr>
+              <a:lnSpc>
+                <a:spcPct val="150000"/>
+              </a:lnSpc>
+              <a:buNone/>
+            </a:pPr>
+            <a:r>
+              <a:rPr kumimoji="0" lang="en-US" altLang="en-US" sz="1300" b="0" i="0" u="none" strike="noStrike" cap="none" normalizeH="0" baseline="0">
+                <a:ln>
+                  <a:noFill/>
+                </a:ln>
+                <a:solidFill>
+                  <a:schemeClr val="tx1"/>
+                </a:solidFill>
+                <a:effectLst/>
+                <a:latin typeface="Arial" panose="020B0604020202020204" pitchFamily="34" charset="0"/>
+              </a:rPr>
+              <a:t>.</a:t>
+            </a:r>
+          </a:p>
+        </p:txBody>
+      </p:sp>
+      <p:pic>
+        <p:nvPicPr>
+          <p:cNvPr id="4" name="Picture 3">
+            <a:extLst>
+              <a:ext uri="{FF2B5EF4-FFF2-40B4-BE49-F238E27FC236}">
+                <a16:creationId xmlns:a16="http://schemas.microsoft.com/office/drawing/2014/main" id="{02F866D5-751C-0B84-6AC1-C54654CD7A88}"/>
+              </a:ext>
+            </a:extLst>
+          </p:cNvPr>
+          <p:cNvPicPr>
+            <a:picLocks noChangeAspect="1"/>
+          </p:cNvPicPr>
+          <p:nvPr/>
+        </p:nvPicPr>
+        <p:blipFill>
+          <a:blip r:embed="rId2"/>
+          <a:stretch>
+            <a:fillRect/>
+          </a:stretch>
+        </p:blipFill>
+        <p:spPr>
+          <a:xfrm>
+            <a:off x="0" y="1665956"/>
+            <a:ext cx="12192000" cy="3526087"/>
+          </a:xfrm>
+          <a:prstGeom prst="rect">
+            <a:avLst/>
+          </a:prstGeom>
+          <a:solidFill>
+            <a:srgbClr val="FFFFFF">
+              <a:shade val="85000"/>
+            </a:srgbClr>
+          </a:solidFill>
+          <a:ln w="88900" cap="sq">
+            <a:solidFill>
+              <a:srgbClr val="FFFFFF"/>
+            </a:solidFill>
+            <a:miter lim="800000"/>
+          </a:ln>
+          <a:effectLst>
+            <a:outerShdw blurRad="55000" dist="18000" dir="5400000" algn="tl" rotWithShape="0">
+              <a:srgbClr val="000000">
+                <a:alpha val="40000"/>
+              </a:srgbClr>
+            </a:outerShdw>
+          </a:effectLst>
+          <a:scene3d>
+            <a:camera prst="orthographicFront"/>
+            <a:lightRig rig="twoPt" dir="t">
+              <a:rot lat="0" lon="0" rev="7200000"/>
+            </a:lightRig>
+          </a:scene3d>
+          <a:sp3d>
+            <a:bevelT w="25400" h="19050"/>
+            <a:contourClr>
+              <a:srgbClr val="FFFFFF"/>
+            </a:contourClr>
+          </a:sp3d>
+        </p:spPr>
+      </p:pic>
+    </p:spTree>
+    <p:extLst>
+      <p:ext uri="{BB962C8B-B14F-4D97-AF65-F5344CB8AC3E}">
+        <p14:creationId xmlns:p14="http://schemas.microsoft.com/office/powerpoint/2010/main" val="3585423443"/>
+      </p:ext>
+    </p:extLst>
+  </p:cSld>
+  <p:clrMapOvr>
+    <a:masterClrMapping/>
+  </p:clrMapOvr>
+</p:sld>
+</file>
+
+<file path=ppt/slides/slide8.xml><?xml version="1.0" encoding="utf-8"?>
 <p:sld xmlns:a="http://schemas.openxmlformats.org/drawingml/2006/main" xmlns:r="http://schemas.openxmlformats.org/officeDocument/2006/relationships" xmlns:p="http://schemas.openxmlformats.org/presentationml/2006/main">
   <p:cSld>
     <p:spTree>
@@ -3730,10 +4678,156 @@
           </a:p>
         </p:txBody>
       </p:sp>
+      <p:pic>
+        <p:nvPicPr>
+          <p:cNvPr id="4" name="Picture 3">
+            <a:extLst>
+              <a:ext uri="{FF2B5EF4-FFF2-40B4-BE49-F238E27FC236}">
+                <a16:creationId xmlns:a16="http://schemas.microsoft.com/office/drawing/2014/main" id="{8A5EEFD6-E091-0D24-0F9C-2480CC194CD8}"/>
+              </a:ext>
+            </a:extLst>
+          </p:cNvPr>
+          <p:cNvPicPr>
+            <a:picLocks noChangeAspect="1"/>
+          </p:cNvPicPr>
+          <p:nvPr/>
+        </p:nvPicPr>
+        <p:blipFill>
+          <a:blip r:embed="rId2"/>
+          <a:stretch>
+            <a:fillRect/>
+          </a:stretch>
+        </p:blipFill>
+        <p:spPr>
+          <a:xfrm>
+            <a:off x="1208972" y="0"/>
+            <a:ext cx="9774055" cy="6858000"/>
+          </a:xfrm>
+          <a:prstGeom prst="rect">
+            <a:avLst/>
+          </a:prstGeom>
+        </p:spPr>
+      </p:pic>
     </p:spTree>
     <p:extLst>
       <p:ext uri="{BB962C8B-B14F-4D97-AF65-F5344CB8AC3E}">
         <p14:creationId xmlns:p14="http://schemas.microsoft.com/office/powerpoint/2010/main" val="616314994"/>
+      </p:ext>
+    </p:extLst>
+  </p:cSld>
+  <p:clrMapOvr>
+    <a:masterClrMapping/>
+  </p:clrMapOvr>
+</p:sld>
+</file>
+
+<file path=ppt/slides/slide9.xml><?xml version="1.0" encoding="utf-8"?>
+<p:sld xmlns:a="http://schemas.openxmlformats.org/drawingml/2006/main" xmlns:r="http://schemas.openxmlformats.org/officeDocument/2006/relationships" xmlns:p="http://schemas.openxmlformats.org/presentationml/2006/main">
+  <p:cSld>
+    <p:spTree>
+      <p:nvGrpSpPr>
+        <p:cNvPr id="1" name="">
+          <a:extLst>
+            <a:ext uri="{FF2B5EF4-FFF2-40B4-BE49-F238E27FC236}">
+              <a16:creationId xmlns:a16="http://schemas.microsoft.com/office/drawing/2014/main" id="{0D1E49FD-29DF-5008-7FB4-A4708709821C}"/>
+            </a:ext>
+          </a:extLst>
+        </p:cNvPr>
+        <p:cNvGrpSpPr/>
+        <p:nvPr/>
+      </p:nvGrpSpPr>
+      <p:grpSpPr>
+        <a:xfrm>
+          <a:off x="0" y="0"/>
+          <a:ext cx="0" cy="0"/>
+          <a:chOff x="0" y="0"/>
+          <a:chExt cx="0" cy="0"/>
+        </a:xfrm>
+      </p:grpSpPr>
+      <p:sp>
+        <p:nvSpPr>
+          <p:cNvPr id="3" name="TextBox 2">
+            <a:extLst>
+              <a:ext uri="{FF2B5EF4-FFF2-40B4-BE49-F238E27FC236}">
+                <a16:creationId xmlns:a16="http://schemas.microsoft.com/office/drawing/2014/main" id="{4E78270C-FEE5-DD81-C58E-4F4C89E4B951}"/>
+              </a:ext>
+            </a:extLst>
+          </p:cNvPr>
+          <p:cNvSpPr txBox="1"/>
+          <p:nvPr/>
+        </p:nvSpPr>
+        <p:spPr>
+          <a:xfrm>
+            <a:off x="0" y="0"/>
+            <a:ext cx="12192000" cy="355354"/>
+          </a:xfrm>
+          <a:prstGeom prst="rect">
+            <a:avLst/>
+          </a:prstGeom>
+          <a:noFill/>
+        </p:spPr>
+        <p:txBody>
+          <a:bodyPr wrap="square">
+            <a:spAutoFit/>
+          </a:bodyPr>
+          <a:lstStyle/>
+          <a:p>
+            <a:pPr>
+              <a:lnSpc>
+                <a:spcPct val="150000"/>
+              </a:lnSpc>
+              <a:buNone/>
+            </a:pPr>
+            <a:r>
+              <a:rPr kumimoji="0" lang="en-US" altLang="en-US" sz="1300" b="0" i="0" u="none" strike="noStrike" cap="none" normalizeH="0" baseline="0">
+                <a:ln>
+                  <a:noFill/>
+                </a:ln>
+                <a:solidFill>
+                  <a:schemeClr val="tx1"/>
+                </a:solidFill>
+                <a:effectLst/>
+                <a:latin typeface="Arial" panose="020B0604020202020204" pitchFamily="34" charset="0"/>
+              </a:rPr>
+              <a:t>.</a:t>
+            </a:r>
+          </a:p>
+        </p:txBody>
+      </p:sp>
+      <p:pic>
+        <p:nvPicPr>
+          <p:cNvPr id="4" name="Picture 3">
+            <a:extLst>
+              <a:ext uri="{FF2B5EF4-FFF2-40B4-BE49-F238E27FC236}">
+                <a16:creationId xmlns:a16="http://schemas.microsoft.com/office/drawing/2014/main" id="{51196F5E-0611-BB20-CE47-0920DBB25E92}"/>
+              </a:ext>
+            </a:extLst>
+          </p:cNvPr>
+          <p:cNvPicPr>
+            <a:picLocks noChangeAspect="1"/>
+          </p:cNvPicPr>
+          <p:nvPr/>
+        </p:nvPicPr>
+        <p:blipFill>
+          <a:blip r:embed="rId2"/>
+          <a:stretch>
+            <a:fillRect/>
+          </a:stretch>
+        </p:blipFill>
+        <p:spPr>
+          <a:xfrm>
+            <a:off x="635519" y="0"/>
+            <a:ext cx="10920962" cy="6858000"/>
+          </a:xfrm>
+          <a:prstGeom prst="rect">
+            <a:avLst/>
+          </a:prstGeom>
+        </p:spPr>
+      </p:pic>
+    </p:spTree>
+    <p:extLst>
+      <p:ext uri="{BB962C8B-B14F-4D97-AF65-F5344CB8AC3E}">
+        <p14:creationId xmlns:p14="http://schemas.microsoft.com/office/powerpoint/2010/main" val="3613683330"/>
       </p:ext>
     </p:extLst>
   </p:cSld>

</xml_diff>